<commit_message>
Brushup on logos etc
</commit_message>
<xml_diff>
--- a/21_September_Monday/02_Intro_and_General_Concepts/02_McStas_McXtrace_Common_Introduction.pptx
+++ b/21_September_Monday/02_Intro_and_General_Concepts/02_McStas_McXtrace_Common_Introduction.pptx
@@ -124,6 +124,11 @@
       </a:defRPr>
     </a:lvl9pPr>
   </p:defaultTextStyle>
+  <p:extLst>
+    <p:ext uri="{EFAFB233-063F-42B5-8137-9DF3F51BA10A}">
+      <p15:sldGuideLst xmlns:p15="http://schemas.microsoft.com/office/powerpoint/2012/main"/>
+    </p:ext>
+  </p:extLst>
 </p:presentation>
 </file>
 
@@ -7172,7 +7177,7 @@
         </p:nvGraphicFramePr>
         <p:xfrm>
           <a:off x="548640" y="1691640"/>
-          <a:ext cx="11063880" cy="2743200"/>
+          <a:ext cx="11064240" cy="2743200"/>
         </p:xfrm>
         <a:graphic>
           <a:graphicData uri="http://schemas.openxmlformats.org/drawingml/2006/table">
@@ -8512,6 +8517,189 @@
           </a:ln>
         </p:spPr>
       </p:pic>
+      <p:grpSp>
+        <p:nvGrpSpPr>
+          <p:cNvPr id="3" name="Group 2">
+            <a:extLst>
+              <a:ext uri="{FF2B5EF4-FFF2-40B4-BE49-F238E27FC236}">
+                <a16:creationId xmlns:a16="http://schemas.microsoft.com/office/drawing/2014/main" id="{786858F7-1C17-4693-E610-7E448CB8922E}"/>
+              </a:ext>
+            </a:extLst>
+          </p:cNvPr>
+          <p:cNvGrpSpPr/>
+          <p:nvPr/>
+        </p:nvGrpSpPr>
+        <p:grpSpPr>
+          <a:xfrm>
+            <a:off x="8424360" y="119520"/>
+            <a:ext cx="1590840" cy="748800"/>
+            <a:chOff x="8424360" y="119520"/>
+            <a:chExt cx="1590840" cy="748800"/>
+          </a:xfrm>
+        </p:grpSpPr>
+        <p:grpSp>
+          <p:nvGrpSpPr>
+            <p:cNvPr id="4" name="Group 3">
+              <a:extLst>
+                <a:ext uri="{FF2B5EF4-FFF2-40B4-BE49-F238E27FC236}">
+                  <a16:creationId xmlns:a16="http://schemas.microsoft.com/office/drawing/2014/main" id="{9468A88E-1534-DCD8-935B-05E811A0D878}"/>
+                </a:ext>
+              </a:extLst>
+            </p:cNvPr>
+            <p:cNvGrpSpPr/>
+            <p:nvPr/>
+          </p:nvGrpSpPr>
+          <p:grpSpPr>
+            <a:xfrm>
+              <a:off x="9225000" y="124302"/>
+              <a:ext cx="790200" cy="708378"/>
+              <a:chOff x="9225000" y="124302"/>
+              <a:chExt cx="790200" cy="708378"/>
+            </a:xfrm>
+          </p:grpSpPr>
+          <p:pic>
+            <p:nvPicPr>
+              <p:cNvPr id="6" name="Picture 5">
+                <a:extLst>
+                  <a:ext uri="{FF2B5EF4-FFF2-40B4-BE49-F238E27FC236}">
+                    <a16:creationId xmlns:a16="http://schemas.microsoft.com/office/drawing/2014/main" id="{6DA8B590-26E5-4D46-EA3F-0E74D231FC06}"/>
+                  </a:ext>
+                </a:extLst>
+              </p:cNvPr>
+              <p:cNvPicPr>
+                <a:picLocks noChangeAspect="1"/>
+              </p:cNvPicPr>
+              <p:nvPr/>
+            </p:nvPicPr>
+            <p:blipFill>
+              <a:blip r:embed="rId5"/>
+              <a:stretch>
+                <a:fillRect/>
+              </a:stretch>
+            </p:blipFill>
+            <p:spPr>
+              <a:xfrm>
+                <a:off x="9262056" y="124302"/>
+                <a:ext cx="716666" cy="424533"/>
+              </a:xfrm>
+              <a:prstGeom prst="rect">
+                <a:avLst/>
+              </a:prstGeom>
+            </p:spPr>
+          </p:pic>
+          <p:grpSp>
+            <p:nvGrpSpPr>
+              <p:cNvPr id="7" name="Group 32">
+                <a:extLst>
+                  <a:ext uri="{FF2B5EF4-FFF2-40B4-BE49-F238E27FC236}">
+                    <a16:creationId xmlns:a16="http://schemas.microsoft.com/office/drawing/2014/main" id="{01D520B4-3D30-084B-805D-F40A29816488}"/>
+                  </a:ext>
+                </a:extLst>
+              </p:cNvPr>
+              <p:cNvGrpSpPr/>
+              <p:nvPr/>
+            </p:nvGrpSpPr>
+            <p:grpSpPr>
+              <a:xfrm>
+                <a:off x="9225000" y="531360"/>
+                <a:ext cx="790200" cy="301320"/>
+                <a:chOff x="9225000" y="531360"/>
+                <a:chExt cx="790200" cy="301320"/>
+              </a:xfrm>
+            </p:grpSpPr>
+            <p:pic>
+              <p:nvPicPr>
+                <p:cNvPr id="8" name="Picture 29" descr="Synchrotron SOLEIL">
+                  <a:extLst>
+                    <a:ext uri="{FF2B5EF4-FFF2-40B4-BE49-F238E27FC236}">
+                      <a16:creationId xmlns:a16="http://schemas.microsoft.com/office/drawing/2014/main" id="{5C605313-95C9-D0B1-54E1-CA7E3C1A3D53}"/>
+                    </a:ext>
+                  </a:extLst>
+                </p:cNvPr>
+                <p:cNvPicPr/>
+                <p:nvPr/>
+              </p:nvPicPr>
+              <p:blipFill>
+                <a:blip r:embed="rId6"/>
+                <a:stretch/>
+              </p:blipFill>
+              <p:spPr>
+                <a:xfrm>
+                  <a:off x="9225000" y="531360"/>
+                  <a:ext cx="547920" cy="264600"/>
+                </a:xfrm>
+                <a:prstGeom prst="rect">
+                  <a:avLst/>
+                </a:prstGeom>
+                <a:noFill/>
+                <a:ln w="0">
+                  <a:noFill/>
+                </a:ln>
+              </p:spPr>
+            </p:pic>
+            <p:pic>
+              <p:nvPicPr>
+                <p:cNvPr id="9" name="Picture 30" descr="DTU Physics">
+                  <a:extLst>
+                    <a:ext uri="{FF2B5EF4-FFF2-40B4-BE49-F238E27FC236}">
+                      <a16:creationId xmlns:a16="http://schemas.microsoft.com/office/drawing/2014/main" id="{EFDFE51B-8FAE-7893-5DF8-BDBAEC77B16C}"/>
+                    </a:ext>
+                  </a:extLst>
+                </p:cNvPr>
+                <p:cNvPicPr/>
+                <p:nvPr/>
+              </p:nvPicPr>
+              <p:blipFill>
+                <a:blip r:embed="rId7"/>
+                <a:stretch/>
+              </p:blipFill>
+              <p:spPr>
+                <a:xfrm>
+                  <a:off x="9814320" y="536400"/>
+                  <a:ext cx="200880" cy="296280"/>
+                </a:xfrm>
+                <a:prstGeom prst="rect">
+                  <a:avLst/>
+                </a:prstGeom>
+                <a:noFill/>
+                <a:ln w="0">
+                  <a:noFill/>
+                </a:ln>
+              </p:spPr>
+            </p:pic>
+          </p:grpSp>
+        </p:grpSp>
+        <p:pic>
+          <p:nvPicPr>
+            <p:cNvPr id="5" name="Picture 31">
+              <a:extLst>
+                <a:ext uri="{FF2B5EF4-FFF2-40B4-BE49-F238E27FC236}">
+                  <a16:creationId xmlns:a16="http://schemas.microsoft.com/office/drawing/2014/main" id="{B5C363F2-14A6-C6F0-F66D-D13D7C79F25D}"/>
+                </a:ext>
+              </a:extLst>
+            </p:cNvPr>
+            <p:cNvPicPr/>
+            <p:nvPr/>
+          </p:nvPicPr>
+          <p:blipFill>
+            <a:blip r:embed="rId8"/>
+            <a:stretch/>
+          </p:blipFill>
+          <p:spPr>
+            <a:xfrm>
+              <a:off x="8424360" y="119520"/>
+              <a:ext cx="736200" cy="748800"/>
+            </a:xfrm>
+            <a:prstGeom prst="rect">
+              <a:avLst/>
+            </a:prstGeom>
+            <a:noFill/>
+            <a:ln w="0">
+              <a:noFill/>
+            </a:ln>
+          </p:spPr>
+        </p:pic>
+      </p:grpSp>
     </p:spTree>
   </p:cSld>
   <p:clrMapOvr>
@@ -11121,6 +11309,309 @@
           </a:ln>
         </p:spPr>
       </p:pic>
+      <p:grpSp>
+        <p:nvGrpSpPr>
+          <p:cNvPr id="2" name="Group 1">
+            <a:extLst>
+              <a:ext uri="{FF2B5EF4-FFF2-40B4-BE49-F238E27FC236}">
+                <a16:creationId xmlns:a16="http://schemas.microsoft.com/office/drawing/2014/main" id="{E0ED8F97-B194-6FB9-2BEA-DF2CC01ED27E}"/>
+              </a:ext>
+            </a:extLst>
+          </p:cNvPr>
+          <p:cNvGrpSpPr/>
+          <p:nvPr/>
+        </p:nvGrpSpPr>
+        <p:grpSpPr>
+          <a:xfrm>
+            <a:off x="8424360" y="119520"/>
+            <a:ext cx="1590840" cy="748800"/>
+            <a:chOff x="8424360" y="119520"/>
+            <a:chExt cx="1590840" cy="748800"/>
+          </a:xfrm>
+        </p:grpSpPr>
+        <p:grpSp>
+          <p:nvGrpSpPr>
+            <p:cNvPr id="3" name="Group 2">
+              <a:extLst>
+                <a:ext uri="{FF2B5EF4-FFF2-40B4-BE49-F238E27FC236}">
+                  <a16:creationId xmlns:a16="http://schemas.microsoft.com/office/drawing/2014/main" id="{9E5344F8-47D0-088D-B1EC-C38D0702DD20}"/>
+                </a:ext>
+              </a:extLst>
+            </p:cNvPr>
+            <p:cNvGrpSpPr/>
+            <p:nvPr/>
+          </p:nvGrpSpPr>
+          <p:grpSpPr>
+            <a:xfrm>
+              <a:off x="9225000" y="124302"/>
+              <a:ext cx="790200" cy="708378"/>
+              <a:chOff x="9225000" y="124302"/>
+              <a:chExt cx="790200" cy="708378"/>
+            </a:xfrm>
+          </p:grpSpPr>
+          <p:pic>
+            <p:nvPicPr>
+              <p:cNvPr id="5" name="Picture 4">
+                <a:extLst>
+                  <a:ext uri="{FF2B5EF4-FFF2-40B4-BE49-F238E27FC236}">
+                    <a16:creationId xmlns:a16="http://schemas.microsoft.com/office/drawing/2014/main" id="{80C4B9A1-29AA-69FD-5A41-D5FD38DF4A67}"/>
+                  </a:ext>
+                </a:extLst>
+              </p:cNvPr>
+              <p:cNvPicPr>
+                <a:picLocks noChangeAspect="1"/>
+              </p:cNvPicPr>
+              <p:nvPr/>
+            </p:nvPicPr>
+            <p:blipFill>
+              <a:blip r:embed="rId5"/>
+              <a:stretch>
+                <a:fillRect/>
+              </a:stretch>
+            </p:blipFill>
+            <p:spPr>
+              <a:xfrm>
+                <a:off x="9262056" y="124302"/>
+                <a:ext cx="716666" cy="424533"/>
+              </a:xfrm>
+              <a:prstGeom prst="rect">
+                <a:avLst/>
+              </a:prstGeom>
+            </p:spPr>
+          </p:pic>
+          <p:grpSp>
+            <p:nvGrpSpPr>
+              <p:cNvPr id="6" name="Group 32">
+                <a:extLst>
+                  <a:ext uri="{FF2B5EF4-FFF2-40B4-BE49-F238E27FC236}">
+                    <a16:creationId xmlns:a16="http://schemas.microsoft.com/office/drawing/2014/main" id="{350BAD29-5F4F-956E-25E0-4DEEB6A4B761}"/>
+                  </a:ext>
+                </a:extLst>
+              </p:cNvPr>
+              <p:cNvGrpSpPr/>
+              <p:nvPr/>
+            </p:nvGrpSpPr>
+            <p:grpSpPr>
+              <a:xfrm>
+                <a:off x="9225000" y="531360"/>
+                <a:ext cx="790200" cy="301320"/>
+                <a:chOff x="9225000" y="531360"/>
+                <a:chExt cx="790200" cy="301320"/>
+              </a:xfrm>
+            </p:grpSpPr>
+            <p:pic>
+              <p:nvPicPr>
+                <p:cNvPr id="7" name="Picture 29" descr="Synchrotron SOLEIL">
+                  <a:extLst>
+                    <a:ext uri="{FF2B5EF4-FFF2-40B4-BE49-F238E27FC236}">
+                      <a16:creationId xmlns:a16="http://schemas.microsoft.com/office/drawing/2014/main" id="{DD0AF014-7BA5-C9E1-AE73-A53631D5CC76}"/>
+                    </a:ext>
+                  </a:extLst>
+                </p:cNvPr>
+                <p:cNvPicPr/>
+                <p:nvPr/>
+              </p:nvPicPr>
+              <p:blipFill>
+                <a:blip r:embed="rId6"/>
+                <a:stretch/>
+              </p:blipFill>
+              <p:spPr>
+                <a:xfrm>
+                  <a:off x="9225000" y="531360"/>
+                  <a:ext cx="547920" cy="264600"/>
+                </a:xfrm>
+                <a:prstGeom prst="rect">
+                  <a:avLst/>
+                </a:prstGeom>
+                <a:noFill/>
+                <a:ln w="0">
+                  <a:noFill/>
+                </a:ln>
+              </p:spPr>
+            </p:pic>
+            <p:pic>
+              <p:nvPicPr>
+                <p:cNvPr id="8" name="Picture 30" descr="DTU Physics">
+                  <a:extLst>
+                    <a:ext uri="{FF2B5EF4-FFF2-40B4-BE49-F238E27FC236}">
+                      <a16:creationId xmlns:a16="http://schemas.microsoft.com/office/drawing/2014/main" id="{AFFD67EA-78AB-84E8-A958-9541B1987306}"/>
+                    </a:ext>
+                  </a:extLst>
+                </p:cNvPr>
+                <p:cNvPicPr/>
+                <p:nvPr/>
+              </p:nvPicPr>
+              <p:blipFill>
+                <a:blip r:embed="rId7"/>
+                <a:stretch/>
+              </p:blipFill>
+              <p:spPr>
+                <a:xfrm>
+                  <a:off x="9814320" y="536400"/>
+                  <a:ext cx="200880" cy="296280"/>
+                </a:xfrm>
+                <a:prstGeom prst="rect">
+                  <a:avLst/>
+                </a:prstGeom>
+                <a:noFill/>
+                <a:ln w="0">
+                  <a:noFill/>
+                </a:ln>
+              </p:spPr>
+            </p:pic>
+          </p:grpSp>
+        </p:grpSp>
+        <p:pic>
+          <p:nvPicPr>
+            <p:cNvPr id="4" name="Picture 31">
+              <a:extLst>
+                <a:ext uri="{FF2B5EF4-FFF2-40B4-BE49-F238E27FC236}">
+                  <a16:creationId xmlns:a16="http://schemas.microsoft.com/office/drawing/2014/main" id="{FE73AE08-C324-1724-59F1-903A7BC77EAD}"/>
+                </a:ext>
+              </a:extLst>
+            </p:cNvPr>
+            <p:cNvPicPr/>
+            <p:nvPr/>
+          </p:nvPicPr>
+          <p:blipFill>
+            <a:blip r:embed="rId8"/>
+            <a:stretch/>
+          </p:blipFill>
+          <p:spPr>
+            <a:xfrm>
+              <a:off x="8424360" y="119520"/>
+              <a:ext cx="736200" cy="748800"/>
+            </a:xfrm>
+            <a:prstGeom prst="rect">
+              <a:avLst/>
+            </a:prstGeom>
+            <a:noFill/>
+            <a:ln w="0">
+              <a:noFill/>
+            </a:ln>
+          </p:spPr>
+        </p:pic>
+      </p:grpSp>
+      <p:pic>
+        <p:nvPicPr>
+          <p:cNvPr id="9" name="Picture 31">
+            <a:extLst>
+              <a:ext uri="{FF2B5EF4-FFF2-40B4-BE49-F238E27FC236}">
+                <a16:creationId xmlns:a16="http://schemas.microsoft.com/office/drawing/2014/main" id="{CB041D61-C6BF-5A09-77F0-230647A6ED32}"/>
+              </a:ext>
+            </a:extLst>
+          </p:cNvPr>
+          <p:cNvPicPr/>
+          <p:nvPr/>
+        </p:nvPicPr>
+        <p:blipFill>
+          <a:blip r:embed="rId8"/>
+          <a:stretch/>
+        </p:blipFill>
+        <p:spPr>
+          <a:xfrm>
+            <a:off x="4932900" y="2084490"/>
+            <a:ext cx="736200" cy="748800"/>
+          </a:xfrm>
+          <a:prstGeom prst="rect">
+            <a:avLst/>
+          </a:prstGeom>
+          <a:noFill/>
+          <a:ln w="0">
+            <a:noFill/>
+          </a:ln>
+        </p:spPr>
+      </p:pic>
+      <p:pic>
+        <p:nvPicPr>
+          <p:cNvPr id="10" name="Picture 9">
+            <a:extLst>
+              <a:ext uri="{FF2B5EF4-FFF2-40B4-BE49-F238E27FC236}">
+                <a16:creationId xmlns:a16="http://schemas.microsoft.com/office/drawing/2014/main" id="{A83F7A09-234D-870E-46F7-5A1ACCD2D18F}"/>
+              </a:ext>
+            </a:extLst>
+          </p:cNvPr>
+          <p:cNvPicPr>
+            <a:picLocks noChangeAspect="1"/>
+          </p:cNvPicPr>
+          <p:nvPr/>
+        </p:nvPicPr>
+        <p:blipFill>
+          <a:blip r:embed="rId5"/>
+          <a:stretch>
+            <a:fillRect/>
+          </a:stretch>
+        </p:blipFill>
+        <p:spPr>
+          <a:xfrm>
+            <a:off x="10516187" y="2074680"/>
+            <a:ext cx="716666" cy="424533"/>
+          </a:xfrm>
+          <a:prstGeom prst="rect">
+            <a:avLst/>
+          </a:prstGeom>
+        </p:spPr>
+      </p:pic>
+      <p:pic>
+        <p:nvPicPr>
+          <p:cNvPr id="11" name="Picture 29" descr="Synchrotron SOLEIL">
+            <a:extLst>
+              <a:ext uri="{FF2B5EF4-FFF2-40B4-BE49-F238E27FC236}">
+                <a16:creationId xmlns:a16="http://schemas.microsoft.com/office/drawing/2014/main" id="{F1760011-BA1F-A85A-8399-816B75A49729}"/>
+              </a:ext>
+            </a:extLst>
+          </p:cNvPr>
+          <p:cNvPicPr/>
+          <p:nvPr/>
+        </p:nvPicPr>
+        <p:blipFill>
+          <a:blip r:embed="rId6"/>
+          <a:stretch/>
+        </p:blipFill>
+        <p:spPr>
+          <a:xfrm>
+            <a:off x="10479131" y="2481738"/>
+            <a:ext cx="547920" cy="264600"/>
+          </a:xfrm>
+          <a:prstGeom prst="rect">
+            <a:avLst/>
+          </a:prstGeom>
+          <a:noFill/>
+          <a:ln w="0">
+            <a:noFill/>
+          </a:ln>
+        </p:spPr>
+      </p:pic>
+      <p:pic>
+        <p:nvPicPr>
+          <p:cNvPr id="12" name="Picture 30" descr="DTU Physics">
+            <a:extLst>
+              <a:ext uri="{FF2B5EF4-FFF2-40B4-BE49-F238E27FC236}">
+                <a16:creationId xmlns:a16="http://schemas.microsoft.com/office/drawing/2014/main" id="{34D96D23-B9DD-31F5-EB9E-74B0FF1BA64C}"/>
+              </a:ext>
+            </a:extLst>
+          </p:cNvPr>
+          <p:cNvPicPr/>
+          <p:nvPr/>
+        </p:nvPicPr>
+        <p:blipFill>
+          <a:blip r:embed="rId7"/>
+          <a:stretch/>
+        </p:blipFill>
+        <p:spPr>
+          <a:xfrm>
+            <a:off x="11068451" y="2486778"/>
+            <a:ext cx="200880" cy="296280"/>
+          </a:xfrm>
+          <a:prstGeom prst="rect">
+            <a:avLst/>
+          </a:prstGeom>
+          <a:noFill/>
+          <a:ln w="0">
+            <a:noFill/>
+          </a:ln>
+        </p:spPr>
+      </p:pic>
     </p:spTree>
   </p:cSld>
   <p:clrMapOvr>
@@ -15078,6 +15569,189 @@
             </a:prstGeom>
             <a:noFill/>
             <a:ln w="12700">
+              <a:noFill/>
+            </a:ln>
+          </p:spPr>
+        </p:pic>
+      </p:grpSp>
+      <p:grpSp>
+        <p:nvGrpSpPr>
+          <p:cNvPr id="5" name="Group 4">
+            <a:extLst>
+              <a:ext uri="{FF2B5EF4-FFF2-40B4-BE49-F238E27FC236}">
+                <a16:creationId xmlns:a16="http://schemas.microsoft.com/office/drawing/2014/main" id="{88737D9F-0724-7739-AA44-255EE82C787F}"/>
+              </a:ext>
+            </a:extLst>
+          </p:cNvPr>
+          <p:cNvGrpSpPr/>
+          <p:nvPr/>
+        </p:nvGrpSpPr>
+        <p:grpSpPr>
+          <a:xfrm>
+            <a:off x="8424360" y="119520"/>
+            <a:ext cx="1590840" cy="748800"/>
+            <a:chOff x="8424360" y="119520"/>
+            <a:chExt cx="1590840" cy="748800"/>
+          </a:xfrm>
+        </p:grpSpPr>
+        <p:grpSp>
+          <p:nvGrpSpPr>
+            <p:cNvPr id="6" name="Group 5">
+              <a:extLst>
+                <a:ext uri="{FF2B5EF4-FFF2-40B4-BE49-F238E27FC236}">
+                  <a16:creationId xmlns:a16="http://schemas.microsoft.com/office/drawing/2014/main" id="{C1F80C8F-E676-18BD-6D9F-8D1FCA36A00C}"/>
+                </a:ext>
+              </a:extLst>
+            </p:cNvPr>
+            <p:cNvGrpSpPr/>
+            <p:nvPr/>
+          </p:nvGrpSpPr>
+          <p:grpSpPr>
+            <a:xfrm>
+              <a:off x="9225000" y="124302"/>
+              <a:ext cx="790200" cy="708378"/>
+              <a:chOff x="9225000" y="124302"/>
+              <a:chExt cx="790200" cy="708378"/>
+            </a:xfrm>
+          </p:grpSpPr>
+          <p:pic>
+            <p:nvPicPr>
+              <p:cNvPr id="8" name="Picture 7">
+                <a:extLst>
+                  <a:ext uri="{FF2B5EF4-FFF2-40B4-BE49-F238E27FC236}">
+                    <a16:creationId xmlns:a16="http://schemas.microsoft.com/office/drawing/2014/main" id="{D99047B9-0E3B-1F8B-9737-986CBE7258E7}"/>
+                  </a:ext>
+                </a:extLst>
+              </p:cNvPr>
+              <p:cNvPicPr>
+                <a:picLocks noChangeAspect="1"/>
+              </p:cNvPicPr>
+              <p:nvPr/>
+            </p:nvPicPr>
+            <p:blipFill>
+              <a:blip r:embed="rId7"/>
+              <a:stretch>
+                <a:fillRect/>
+              </a:stretch>
+            </p:blipFill>
+            <p:spPr>
+              <a:xfrm>
+                <a:off x="9262056" y="124302"/>
+                <a:ext cx="716666" cy="424533"/>
+              </a:xfrm>
+              <a:prstGeom prst="rect">
+                <a:avLst/>
+              </a:prstGeom>
+            </p:spPr>
+          </p:pic>
+          <p:grpSp>
+            <p:nvGrpSpPr>
+              <p:cNvPr id="9" name="Group 32">
+                <a:extLst>
+                  <a:ext uri="{FF2B5EF4-FFF2-40B4-BE49-F238E27FC236}">
+                    <a16:creationId xmlns:a16="http://schemas.microsoft.com/office/drawing/2014/main" id="{2B93A463-517F-95D4-F431-1BAB5B7868C9}"/>
+                  </a:ext>
+                </a:extLst>
+              </p:cNvPr>
+              <p:cNvGrpSpPr/>
+              <p:nvPr/>
+            </p:nvGrpSpPr>
+            <p:grpSpPr>
+              <a:xfrm>
+                <a:off x="9225000" y="531360"/>
+                <a:ext cx="790200" cy="301320"/>
+                <a:chOff x="9225000" y="531360"/>
+                <a:chExt cx="790200" cy="301320"/>
+              </a:xfrm>
+            </p:grpSpPr>
+            <p:pic>
+              <p:nvPicPr>
+                <p:cNvPr id="10" name="Picture 29" descr="Synchrotron SOLEIL">
+                  <a:extLst>
+                    <a:ext uri="{FF2B5EF4-FFF2-40B4-BE49-F238E27FC236}">
+                      <a16:creationId xmlns:a16="http://schemas.microsoft.com/office/drawing/2014/main" id="{DB689679-8D4E-F68A-D81B-A820C6A408C2}"/>
+                    </a:ext>
+                  </a:extLst>
+                </p:cNvPr>
+                <p:cNvPicPr/>
+                <p:nvPr/>
+              </p:nvPicPr>
+              <p:blipFill>
+                <a:blip r:embed="rId8"/>
+                <a:stretch/>
+              </p:blipFill>
+              <p:spPr>
+                <a:xfrm>
+                  <a:off x="9225000" y="531360"/>
+                  <a:ext cx="547920" cy="264600"/>
+                </a:xfrm>
+                <a:prstGeom prst="rect">
+                  <a:avLst/>
+                </a:prstGeom>
+                <a:noFill/>
+                <a:ln w="0">
+                  <a:noFill/>
+                </a:ln>
+              </p:spPr>
+            </p:pic>
+            <p:pic>
+              <p:nvPicPr>
+                <p:cNvPr id="11" name="Picture 30" descr="DTU Physics">
+                  <a:extLst>
+                    <a:ext uri="{FF2B5EF4-FFF2-40B4-BE49-F238E27FC236}">
+                      <a16:creationId xmlns:a16="http://schemas.microsoft.com/office/drawing/2014/main" id="{B35D196C-78F0-A65F-7CA9-751858A65D26}"/>
+                    </a:ext>
+                  </a:extLst>
+                </p:cNvPr>
+                <p:cNvPicPr/>
+                <p:nvPr/>
+              </p:nvPicPr>
+              <p:blipFill>
+                <a:blip r:embed="rId9"/>
+                <a:stretch/>
+              </p:blipFill>
+              <p:spPr>
+                <a:xfrm>
+                  <a:off x="9814320" y="536400"/>
+                  <a:ext cx="200880" cy="296280"/>
+                </a:xfrm>
+                <a:prstGeom prst="rect">
+                  <a:avLst/>
+                </a:prstGeom>
+                <a:noFill/>
+                <a:ln w="0">
+                  <a:noFill/>
+                </a:ln>
+              </p:spPr>
+            </p:pic>
+          </p:grpSp>
+        </p:grpSp>
+        <p:pic>
+          <p:nvPicPr>
+            <p:cNvPr id="7" name="Picture 31">
+              <a:extLst>
+                <a:ext uri="{FF2B5EF4-FFF2-40B4-BE49-F238E27FC236}">
+                  <a16:creationId xmlns:a16="http://schemas.microsoft.com/office/drawing/2014/main" id="{D51EF62F-BAC9-BE00-343F-742105C7A24F}"/>
+                </a:ext>
+              </a:extLst>
+            </p:cNvPr>
+            <p:cNvPicPr/>
+            <p:nvPr/>
+          </p:nvPicPr>
+          <p:blipFill>
+            <a:blip r:embed="rId10"/>
+            <a:stretch/>
+          </p:blipFill>
+          <p:spPr>
+            <a:xfrm>
+              <a:off x="8424360" y="119520"/>
+              <a:ext cx="736200" cy="748800"/>
+            </a:xfrm>
+            <a:prstGeom prst="rect">
+              <a:avLst/>
+            </a:prstGeom>
+            <a:noFill/>
+            <a:ln w="0">
               <a:noFill/>
             </a:ln>
           </p:spPr>
@@ -17070,6 +17744,189 @@
           </a:p>
         </p:txBody>
       </p:sp>
+      <p:grpSp>
+        <p:nvGrpSpPr>
+          <p:cNvPr id="2" name="Group 1">
+            <a:extLst>
+              <a:ext uri="{FF2B5EF4-FFF2-40B4-BE49-F238E27FC236}">
+                <a16:creationId xmlns:a16="http://schemas.microsoft.com/office/drawing/2014/main" id="{4C44414D-CC82-A144-52CB-C5C1180AAC62}"/>
+              </a:ext>
+            </a:extLst>
+          </p:cNvPr>
+          <p:cNvGrpSpPr/>
+          <p:nvPr/>
+        </p:nvGrpSpPr>
+        <p:grpSpPr>
+          <a:xfrm>
+            <a:off x="8424360" y="119520"/>
+            <a:ext cx="1590840" cy="748800"/>
+            <a:chOff x="8424360" y="119520"/>
+            <a:chExt cx="1590840" cy="748800"/>
+          </a:xfrm>
+        </p:grpSpPr>
+        <p:grpSp>
+          <p:nvGrpSpPr>
+            <p:cNvPr id="6" name="Group 5">
+              <a:extLst>
+                <a:ext uri="{FF2B5EF4-FFF2-40B4-BE49-F238E27FC236}">
+                  <a16:creationId xmlns:a16="http://schemas.microsoft.com/office/drawing/2014/main" id="{6EE8802D-5167-5766-6C4D-855C4920B74A}"/>
+                </a:ext>
+              </a:extLst>
+            </p:cNvPr>
+            <p:cNvGrpSpPr/>
+            <p:nvPr/>
+          </p:nvGrpSpPr>
+          <p:grpSpPr>
+            <a:xfrm>
+              <a:off x="9225000" y="124302"/>
+              <a:ext cx="790200" cy="708378"/>
+              <a:chOff x="9225000" y="124302"/>
+              <a:chExt cx="790200" cy="708378"/>
+            </a:xfrm>
+          </p:grpSpPr>
+          <p:pic>
+            <p:nvPicPr>
+              <p:cNvPr id="8" name="Picture 7">
+                <a:extLst>
+                  <a:ext uri="{FF2B5EF4-FFF2-40B4-BE49-F238E27FC236}">
+                    <a16:creationId xmlns:a16="http://schemas.microsoft.com/office/drawing/2014/main" id="{254DFDE0-7A4D-91E3-F49C-81D22EB700D6}"/>
+                  </a:ext>
+                </a:extLst>
+              </p:cNvPr>
+              <p:cNvPicPr>
+                <a:picLocks noChangeAspect="1"/>
+              </p:cNvPicPr>
+              <p:nvPr/>
+            </p:nvPicPr>
+            <p:blipFill>
+              <a:blip r:embed="rId6"/>
+              <a:stretch>
+                <a:fillRect/>
+              </a:stretch>
+            </p:blipFill>
+            <p:spPr>
+              <a:xfrm>
+                <a:off x="9262056" y="124302"/>
+                <a:ext cx="716666" cy="424533"/>
+              </a:xfrm>
+              <a:prstGeom prst="rect">
+                <a:avLst/>
+              </a:prstGeom>
+            </p:spPr>
+          </p:pic>
+          <p:grpSp>
+            <p:nvGrpSpPr>
+              <p:cNvPr id="9" name="Group 32">
+                <a:extLst>
+                  <a:ext uri="{FF2B5EF4-FFF2-40B4-BE49-F238E27FC236}">
+                    <a16:creationId xmlns:a16="http://schemas.microsoft.com/office/drawing/2014/main" id="{48FF4E8B-035D-453E-23AD-849C3FFA2B0F}"/>
+                  </a:ext>
+                </a:extLst>
+              </p:cNvPr>
+              <p:cNvGrpSpPr/>
+              <p:nvPr/>
+            </p:nvGrpSpPr>
+            <p:grpSpPr>
+              <a:xfrm>
+                <a:off x="9225000" y="531360"/>
+                <a:ext cx="790200" cy="301320"/>
+                <a:chOff x="9225000" y="531360"/>
+                <a:chExt cx="790200" cy="301320"/>
+              </a:xfrm>
+            </p:grpSpPr>
+            <p:pic>
+              <p:nvPicPr>
+                <p:cNvPr id="10" name="Picture 29" descr="Synchrotron SOLEIL">
+                  <a:extLst>
+                    <a:ext uri="{FF2B5EF4-FFF2-40B4-BE49-F238E27FC236}">
+                      <a16:creationId xmlns:a16="http://schemas.microsoft.com/office/drawing/2014/main" id="{303F2926-2ABC-4B85-2215-09294F0649A8}"/>
+                    </a:ext>
+                  </a:extLst>
+                </p:cNvPr>
+                <p:cNvPicPr/>
+                <p:nvPr/>
+              </p:nvPicPr>
+              <p:blipFill>
+                <a:blip r:embed="rId7"/>
+                <a:stretch/>
+              </p:blipFill>
+              <p:spPr>
+                <a:xfrm>
+                  <a:off x="9225000" y="531360"/>
+                  <a:ext cx="547920" cy="264600"/>
+                </a:xfrm>
+                <a:prstGeom prst="rect">
+                  <a:avLst/>
+                </a:prstGeom>
+                <a:noFill/>
+                <a:ln w="0">
+                  <a:noFill/>
+                </a:ln>
+              </p:spPr>
+            </p:pic>
+            <p:pic>
+              <p:nvPicPr>
+                <p:cNvPr id="11" name="Picture 30" descr="DTU Physics">
+                  <a:extLst>
+                    <a:ext uri="{FF2B5EF4-FFF2-40B4-BE49-F238E27FC236}">
+                      <a16:creationId xmlns:a16="http://schemas.microsoft.com/office/drawing/2014/main" id="{79004B83-43D9-0BEC-E721-C5FBA46A6968}"/>
+                    </a:ext>
+                  </a:extLst>
+                </p:cNvPr>
+                <p:cNvPicPr/>
+                <p:nvPr/>
+              </p:nvPicPr>
+              <p:blipFill>
+                <a:blip r:embed="rId8"/>
+                <a:stretch/>
+              </p:blipFill>
+              <p:spPr>
+                <a:xfrm>
+                  <a:off x="9814320" y="536400"/>
+                  <a:ext cx="200880" cy="296280"/>
+                </a:xfrm>
+                <a:prstGeom prst="rect">
+                  <a:avLst/>
+                </a:prstGeom>
+                <a:noFill/>
+                <a:ln w="0">
+                  <a:noFill/>
+                </a:ln>
+              </p:spPr>
+            </p:pic>
+          </p:grpSp>
+        </p:grpSp>
+        <p:pic>
+          <p:nvPicPr>
+            <p:cNvPr id="7" name="Picture 31">
+              <a:extLst>
+                <a:ext uri="{FF2B5EF4-FFF2-40B4-BE49-F238E27FC236}">
+                  <a16:creationId xmlns:a16="http://schemas.microsoft.com/office/drawing/2014/main" id="{5598319D-28A3-E6DB-9372-2B9C0604CF85}"/>
+                </a:ext>
+              </a:extLst>
+            </p:cNvPr>
+            <p:cNvPicPr/>
+            <p:nvPr/>
+          </p:nvPicPr>
+          <p:blipFill>
+            <a:blip r:embed="rId9"/>
+            <a:stretch/>
+          </p:blipFill>
+          <p:spPr>
+            <a:xfrm>
+              <a:off x="8424360" y="119520"/>
+              <a:ext cx="736200" cy="748800"/>
+            </a:xfrm>
+            <a:prstGeom prst="rect">
+              <a:avLst/>
+            </a:prstGeom>
+            <a:noFill/>
+            <a:ln w="0">
+              <a:noFill/>
+            </a:ln>
+          </p:spPr>
+        </p:pic>
+      </p:grpSp>
     </p:spTree>
   </p:cSld>
   <p:clrMapOvr>
@@ -20563,6 +21420,189 @@
           </a:ln>
         </p:spPr>
       </p:pic>
+      <p:grpSp>
+        <p:nvGrpSpPr>
+          <p:cNvPr id="14" name="Group 13">
+            <a:extLst>
+              <a:ext uri="{FF2B5EF4-FFF2-40B4-BE49-F238E27FC236}">
+                <a16:creationId xmlns:a16="http://schemas.microsoft.com/office/drawing/2014/main" id="{0260A58C-4169-7AE9-2294-D8DE33096CEB}"/>
+              </a:ext>
+            </a:extLst>
+          </p:cNvPr>
+          <p:cNvGrpSpPr/>
+          <p:nvPr/>
+        </p:nvGrpSpPr>
+        <p:grpSpPr>
+          <a:xfrm>
+            <a:off x="8424360" y="119520"/>
+            <a:ext cx="1590840" cy="748800"/>
+            <a:chOff x="8424360" y="119520"/>
+            <a:chExt cx="1590840" cy="748800"/>
+          </a:xfrm>
+        </p:grpSpPr>
+        <p:grpSp>
+          <p:nvGrpSpPr>
+            <p:cNvPr id="15" name="Group 14">
+              <a:extLst>
+                <a:ext uri="{FF2B5EF4-FFF2-40B4-BE49-F238E27FC236}">
+                  <a16:creationId xmlns:a16="http://schemas.microsoft.com/office/drawing/2014/main" id="{4C24172D-2227-6933-D8DB-A0197E9AAB00}"/>
+                </a:ext>
+              </a:extLst>
+            </p:cNvPr>
+            <p:cNvGrpSpPr/>
+            <p:nvPr/>
+          </p:nvGrpSpPr>
+          <p:grpSpPr>
+            <a:xfrm>
+              <a:off x="9225000" y="124302"/>
+              <a:ext cx="790200" cy="708378"/>
+              <a:chOff x="9225000" y="124302"/>
+              <a:chExt cx="790200" cy="708378"/>
+            </a:xfrm>
+          </p:grpSpPr>
+          <p:pic>
+            <p:nvPicPr>
+              <p:cNvPr id="17" name="Picture 16">
+                <a:extLst>
+                  <a:ext uri="{FF2B5EF4-FFF2-40B4-BE49-F238E27FC236}">
+                    <a16:creationId xmlns:a16="http://schemas.microsoft.com/office/drawing/2014/main" id="{25F771A7-2F84-B83E-E4B9-E3DD042A3C39}"/>
+                  </a:ext>
+                </a:extLst>
+              </p:cNvPr>
+              <p:cNvPicPr>
+                <a:picLocks noChangeAspect="1"/>
+              </p:cNvPicPr>
+              <p:nvPr/>
+            </p:nvPicPr>
+            <p:blipFill>
+              <a:blip r:embed="rId5"/>
+              <a:stretch>
+                <a:fillRect/>
+              </a:stretch>
+            </p:blipFill>
+            <p:spPr>
+              <a:xfrm>
+                <a:off x="9262056" y="124302"/>
+                <a:ext cx="716666" cy="424533"/>
+              </a:xfrm>
+              <a:prstGeom prst="rect">
+                <a:avLst/>
+              </a:prstGeom>
+            </p:spPr>
+          </p:pic>
+          <p:grpSp>
+            <p:nvGrpSpPr>
+              <p:cNvPr id="18" name="Group 32">
+                <a:extLst>
+                  <a:ext uri="{FF2B5EF4-FFF2-40B4-BE49-F238E27FC236}">
+                    <a16:creationId xmlns:a16="http://schemas.microsoft.com/office/drawing/2014/main" id="{A323AD46-77F3-80B3-B1A3-2980E0AE0398}"/>
+                  </a:ext>
+                </a:extLst>
+              </p:cNvPr>
+              <p:cNvGrpSpPr/>
+              <p:nvPr/>
+            </p:nvGrpSpPr>
+            <p:grpSpPr>
+              <a:xfrm>
+                <a:off x="9225000" y="531360"/>
+                <a:ext cx="790200" cy="301320"/>
+                <a:chOff x="9225000" y="531360"/>
+                <a:chExt cx="790200" cy="301320"/>
+              </a:xfrm>
+            </p:grpSpPr>
+            <p:pic>
+              <p:nvPicPr>
+                <p:cNvPr id="19" name="Picture 29" descr="Synchrotron SOLEIL">
+                  <a:extLst>
+                    <a:ext uri="{FF2B5EF4-FFF2-40B4-BE49-F238E27FC236}">
+                      <a16:creationId xmlns:a16="http://schemas.microsoft.com/office/drawing/2014/main" id="{BA3D4253-26DD-BCEC-E373-B4E82C1742D0}"/>
+                    </a:ext>
+                  </a:extLst>
+                </p:cNvPr>
+                <p:cNvPicPr/>
+                <p:nvPr/>
+              </p:nvPicPr>
+              <p:blipFill>
+                <a:blip r:embed="rId6"/>
+                <a:stretch/>
+              </p:blipFill>
+              <p:spPr>
+                <a:xfrm>
+                  <a:off x="9225000" y="531360"/>
+                  <a:ext cx="547920" cy="264600"/>
+                </a:xfrm>
+                <a:prstGeom prst="rect">
+                  <a:avLst/>
+                </a:prstGeom>
+                <a:noFill/>
+                <a:ln w="0">
+                  <a:noFill/>
+                </a:ln>
+              </p:spPr>
+            </p:pic>
+            <p:pic>
+              <p:nvPicPr>
+                <p:cNvPr id="20" name="Picture 30" descr="DTU Physics">
+                  <a:extLst>
+                    <a:ext uri="{FF2B5EF4-FFF2-40B4-BE49-F238E27FC236}">
+                      <a16:creationId xmlns:a16="http://schemas.microsoft.com/office/drawing/2014/main" id="{C80DE363-8CD8-776B-6387-419279663C48}"/>
+                    </a:ext>
+                  </a:extLst>
+                </p:cNvPr>
+                <p:cNvPicPr/>
+                <p:nvPr/>
+              </p:nvPicPr>
+              <p:blipFill>
+                <a:blip r:embed="rId7"/>
+                <a:stretch/>
+              </p:blipFill>
+              <p:spPr>
+                <a:xfrm>
+                  <a:off x="9814320" y="536400"/>
+                  <a:ext cx="200880" cy="296280"/>
+                </a:xfrm>
+                <a:prstGeom prst="rect">
+                  <a:avLst/>
+                </a:prstGeom>
+                <a:noFill/>
+                <a:ln w="0">
+                  <a:noFill/>
+                </a:ln>
+              </p:spPr>
+            </p:pic>
+          </p:grpSp>
+        </p:grpSp>
+        <p:pic>
+          <p:nvPicPr>
+            <p:cNvPr id="16" name="Picture 31">
+              <a:extLst>
+                <a:ext uri="{FF2B5EF4-FFF2-40B4-BE49-F238E27FC236}">
+                  <a16:creationId xmlns:a16="http://schemas.microsoft.com/office/drawing/2014/main" id="{AAC4C0B7-F76F-1932-3C74-E43DCC7B5C90}"/>
+                </a:ext>
+              </a:extLst>
+            </p:cNvPr>
+            <p:cNvPicPr/>
+            <p:nvPr/>
+          </p:nvPicPr>
+          <p:blipFill>
+            <a:blip r:embed="rId8"/>
+            <a:stretch/>
+          </p:blipFill>
+          <p:spPr>
+            <a:xfrm>
+              <a:off x="8424360" y="119520"/>
+              <a:ext cx="736200" cy="748800"/>
+            </a:xfrm>
+            <a:prstGeom prst="rect">
+              <a:avLst/>
+            </a:prstGeom>
+            <a:noFill/>
+            <a:ln w="0">
+              <a:noFill/>
+            </a:ln>
+          </p:spPr>
+        </p:pic>
+      </p:grpSp>
     </p:spTree>
   </p:cSld>
   <p:clrMapOvr>
@@ -22462,133 +23502,6 @@
           </a:ln>
         </p:spPr>
       </p:pic>
-      <p:grpSp>
-        <p:nvGrpSpPr>
-          <p:cNvPr id="97" name="Group 33"/>
-          <p:cNvGrpSpPr/>
-          <p:nvPr/>
-        </p:nvGrpSpPr>
-        <p:grpSpPr>
-          <a:xfrm>
-            <a:off x="8424360" y="117000"/>
-            <a:ext cx="1590840" cy="751320"/>
-            <a:chOff x="8424360" y="117000"/>
-            <a:chExt cx="1590840" cy="751320"/>
-          </a:xfrm>
-        </p:grpSpPr>
-        <p:grpSp>
-          <p:nvGrpSpPr>
-            <p:cNvPr id="98" name="Group 32"/>
-            <p:cNvGrpSpPr/>
-            <p:nvPr/>
-          </p:nvGrpSpPr>
-          <p:grpSpPr>
-            <a:xfrm>
-              <a:off x="9225000" y="117000"/>
-              <a:ext cx="790200" cy="715680"/>
-              <a:chOff x="9225000" y="117000"/>
-              <a:chExt cx="790200" cy="715680"/>
-            </a:xfrm>
-          </p:grpSpPr>
-          <p:pic>
-            <p:nvPicPr>
-              <p:cNvPr id="99" name="Picture 28"/>
-              <p:cNvPicPr/>
-              <p:nvPr/>
-            </p:nvPicPr>
-            <p:blipFill>
-              <a:blip r:embed="rId6"/>
-              <a:srcRect l="48137"/>
-              <a:stretch/>
-            </p:blipFill>
-            <p:spPr>
-              <a:xfrm>
-                <a:off x="9253440" y="117000"/>
-                <a:ext cx="736200" cy="441360"/>
-              </a:xfrm>
-              <a:prstGeom prst="rect">
-                <a:avLst/>
-              </a:prstGeom>
-              <a:noFill/>
-              <a:ln w="0">
-                <a:noFill/>
-              </a:ln>
-            </p:spPr>
-          </p:pic>
-          <p:pic>
-            <p:nvPicPr>
-              <p:cNvPr id="100" name="Picture 29" descr="Synchrotron SOLEIL"/>
-              <p:cNvPicPr/>
-              <p:nvPr/>
-            </p:nvPicPr>
-            <p:blipFill>
-              <a:blip r:embed="rId7"/>
-              <a:stretch/>
-            </p:blipFill>
-            <p:spPr>
-              <a:xfrm>
-                <a:off x="9225000" y="531360"/>
-                <a:ext cx="547920" cy="264600"/>
-              </a:xfrm>
-              <a:prstGeom prst="rect">
-                <a:avLst/>
-              </a:prstGeom>
-              <a:noFill/>
-              <a:ln w="0">
-                <a:noFill/>
-              </a:ln>
-            </p:spPr>
-          </p:pic>
-          <p:pic>
-            <p:nvPicPr>
-              <p:cNvPr id="101" name="Picture 30" descr="DTU Physics"/>
-              <p:cNvPicPr/>
-              <p:nvPr/>
-            </p:nvPicPr>
-            <p:blipFill>
-              <a:blip r:embed="rId8"/>
-              <a:stretch/>
-            </p:blipFill>
-            <p:spPr>
-              <a:xfrm>
-                <a:off x="9814320" y="536400"/>
-                <a:ext cx="200880" cy="296280"/>
-              </a:xfrm>
-              <a:prstGeom prst="rect">
-                <a:avLst/>
-              </a:prstGeom>
-              <a:noFill/>
-              <a:ln w="0">
-                <a:noFill/>
-              </a:ln>
-            </p:spPr>
-          </p:pic>
-        </p:grpSp>
-        <p:pic>
-          <p:nvPicPr>
-            <p:cNvPr id="102" name="Picture 31"/>
-            <p:cNvPicPr/>
-            <p:nvPr/>
-          </p:nvPicPr>
-          <p:blipFill>
-            <a:blip r:embed="rId9"/>
-            <a:stretch/>
-          </p:blipFill>
-          <p:spPr>
-            <a:xfrm>
-              <a:off x="8424360" y="119520"/>
-              <a:ext cx="736200" cy="748800"/>
-            </a:xfrm>
-            <a:prstGeom prst="rect">
-              <a:avLst/>
-            </a:prstGeom>
-            <a:noFill/>
-            <a:ln w="0">
-              <a:noFill/>
-            </a:ln>
-          </p:spPr>
-        </p:pic>
-      </p:grpSp>
       <p:pic>
         <p:nvPicPr>
           <p:cNvPr id="103" name="Picture 34"/>
@@ -22596,7 +23509,7 @@
           <p:nvPr/>
         </p:nvPicPr>
         <p:blipFill>
-          <a:blip r:embed="rId10"/>
+          <a:blip r:embed="rId6"/>
           <a:stretch/>
         </p:blipFill>
         <p:spPr>
@@ -22620,7 +23533,7 @@
           <p:nvPr/>
         </p:nvPicPr>
         <p:blipFill>
-          <a:blip r:embed="rId11"/>
+          <a:blip r:embed="rId7"/>
           <a:stretch/>
         </p:blipFill>
         <p:spPr>
@@ -22658,7 +23571,7 @@
             <p:nvPr/>
           </p:nvPicPr>
           <p:blipFill>
-            <a:blip r:embed="rId6"/>
+            <a:blip r:embed="rId8"/>
             <a:srcRect l="48137"/>
             <a:stretch/>
           </p:blipFill>
@@ -22683,7 +23596,7 @@
             <p:nvPr/>
           </p:nvPicPr>
           <p:blipFill>
-            <a:blip r:embed="rId7"/>
+            <a:blip r:embed="rId9"/>
             <a:stretch/>
           </p:blipFill>
           <p:spPr>
@@ -22707,13 +23620,196 @@
             <p:nvPr/>
           </p:nvPicPr>
           <p:blipFill>
-            <a:blip r:embed="rId8"/>
+            <a:blip r:embed="rId10"/>
             <a:stretch/>
           </p:blipFill>
           <p:spPr>
             <a:xfrm>
               <a:off x="8955360" y="5668200"/>
               <a:ext cx="200880" cy="296280"/>
+            </a:xfrm>
+            <a:prstGeom prst="rect">
+              <a:avLst/>
+            </a:prstGeom>
+            <a:noFill/>
+            <a:ln w="0">
+              <a:noFill/>
+            </a:ln>
+          </p:spPr>
+        </p:pic>
+      </p:grpSp>
+      <p:grpSp>
+        <p:nvGrpSpPr>
+          <p:cNvPr id="2" name="Group 1">
+            <a:extLst>
+              <a:ext uri="{FF2B5EF4-FFF2-40B4-BE49-F238E27FC236}">
+                <a16:creationId xmlns:a16="http://schemas.microsoft.com/office/drawing/2014/main" id="{76578BEE-2696-92D3-D90E-D4314D20DFCA}"/>
+              </a:ext>
+            </a:extLst>
+          </p:cNvPr>
+          <p:cNvGrpSpPr/>
+          <p:nvPr/>
+        </p:nvGrpSpPr>
+        <p:grpSpPr>
+          <a:xfrm>
+            <a:off x="8424360" y="119520"/>
+            <a:ext cx="1590840" cy="748800"/>
+            <a:chOff x="8424360" y="119520"/>
+            <a:chExt cx="1590840" cy="748800"/>
+          </a:xfrm>
+        </p:grpSpPr>
+        <p:grpSp>
+          <p:nvGrpSpPr>
+            <p:cNvPr id="3" name="Group 2">
+              <a:extLst>
+                <a:ext uri="{FF2B5EF4-FFF2-40B4-BE49-F238E27FC236}">
+                  <a16:creationId xmlns:a16="http://schemas.microsoft.com/office/drawing/2014/main" id="{87D06A79-3CAC-A25F-F9DA-81F0C9ACA600}"/>
+                </a:ext>
+              </a:extLst>
+            </p:cNvPr>
+            <p:cNvGrpSpPr/>
+            <p:nvPr/>
+          </p:nvGrpSpPr>
+          <p:grpSpPr>
+            <a:xfrm>
+              <a:off x="9225000" y="124302"/>
+              <a:ext cx="790200" cy="708378"/>
+              <a:chOff x="9225000" y="124302"/>
+              <a:chExt cx="790200" cy="708378"/>
+            </a:xfrm>
+          </p:grpSpPr>
+          <p:pic>
+            <p:nvPicPr>
+              <p:cNvPr id="5" name="Picture 4">
+                <a:extLst>
+                  <a:ext uri="{FF2B5EF4-FFF2-40B4-BE49-F238E27FC236}">
+                    <a16:creationId xmlns:a16="http://schemas.microsoft.com/office/drawing/2014/main" id="{507D1B0E-9E6A-215D-7991-DE55A0CAFE3A}"/>
+                  </a:ext>
+                </a:extLst>
+              </p:cNvPr>
+              <p:cNvPicPr>
+                <a:picLocks noChangeAspect="1"/>
+              </p:cNvPicPr>
+              <p:nvPr/>
+            </p:nvPicPr>
+            <p:blipFill>
+              <a:blip r:embed="rId11"/>
+              <a:stretch>
+                <a:fillRect/>
+              </a:stretch>
+            </p:blipFill>
+            <p:spPr>
+              <a:xfrm>
+                <a:off x="9262056" y="124302"/>
+                <a:ext cx="716666" cy="424533"/>
+              </a:xfrm>
+              <a:prstGeom prst="rect">
+                <a:avLst/>
+              </a:prstGeom>
+            </p:spPr>
+          </p:pic>
+          <p:grpSp>
+            <p:nvGrpSpPr>
+              <p:cNvPr id="6" name="Group 32">
+                <a:extLst>
+                  <a:ext uri="{FF2B5EF4-FFF2-40B4-BE49-F238E27FC236}">
+                    <a16:creationId xmlns:a16="http://schemas.microsoft.com/office/drawing/2014/main" id="{6367B997-D051-7E26-1D85-BC62331F48FD}"/>
+                  </a:ext>
+                </a:extLst>
+              </p:cNvPr>
+              <p:cNvGrpSpPr/>
+              <p:nvPr/>
+            </p:nvGrpSpPr>
+            <p:grpSpPr>
+              <a:xfrm>
+                <a:off x="9225000" y="531360"/>
+                <a:ext cx="790200" cy="301320"/>
+                <a:chOff x="9225000" y="531360"/>
+                <a:chExt cx="790200" cy="301320"/>
+              </a:xfrm>
+            </p:grpSpPr>
+            <p:pic>
+              <p:nvPicPr>
+                <p:cNvPr id="7" name="Picture 29" descr="Synchrotron SOLEIL">
+                  <a:extLst>
+                    <a:ext uri="{FF2B5EF4-FFF2-40B4-BE49-F238E27FC236}">
+                      <a16:creationId xmlns:a16="http://schemas.microsoft.com/office/drawing/2014/main" id="{3DF87776-99C9-586B-8834-BC132BCAB640}"/>
+                    </a:ext>
+                  </a:extLst>
+                </p:cNvPr>
+                <p:cNvPicPr/>
+                <p:nvPr/>
+              </p:nvPicPr>
+              <p:blipFill>
+                <a:blip r:embed="rId9"/>
+                <a:stretch/>
+              </p:blipFill>
+              <p:spPr>
+                <a:xfrm>
+                  <a:off x="9225000" y="531360"/>
+                  <a:ext cx="547920" cy="264600"/>
+                </a:xfrm>
+                <a:prstGeom prst="rect">
+                  <a:avLst/>
+                </a:prstGeom>
+                <a:noFill/>
+                <a:ln w="0">
+                  <a:noFill/>
+                </a:ln>
+              </p:spPr>
+            </p:pic>
+            <p:pic>
+              <p:nvPicPr>
+                <p:cNvPr id="8" name="Picture 30" descr="DTU Physics">
+                  <a:extLst>
+                    <a:ext uri="{FF2B5EF4-FFF2-40B4-BE49-F238E27FC236}">
+                      <a16:creationId xmlns:a16="http://schemas.microsoft.com/office/drawing/2014/main" id="{3B77F787-E0B7-FB97-7F7F-1166239AF89E}"/>
+                    </a:ext>
+                  </a:extLst>
+                </p:cNvPr>
+                <p:cNvPicPr/>
+                <p:nvPr/>
+              </p:nvPicPr>
+              <p:blipFill>
+                <a:blip r:embed="rId10"/>
+                <a:stretch/>
+              </p:blipFill>
+              <p:spPr>
+                <a:xfrm>
+                  <a:off x="9814320" y="536400"/>
+                  <a:ext cx="200880" cy="296280"/>
+                </a:xfrm>
+                <a:prstGeom prst="rect">
+                  <a:avLst/>
+                </a:prstGeom>
+                <a:noFill/>
+                <a:ln w="0">
+                  <a:noFill/>
+                </a:ln>
+              </p:spPr>
+            </p:pic>
+          </p:grpSp>
+        </p:grpSp>
+        <p:pic>
+          <p:nvPicPr>
+            <p:cNvPr id="4" name="Picture 31">
+              <a:extLst>
+                <a:ext uri="{FF2B5EF4-FFF2-40B4-BE49-F238E27FC236}">
+                  <a16:creationId xmlns:a16="http://schemas.microsoft.com/office/drawing/2014/main" id="{702EDECD-ECF2-AAF5-8361-BA448C1A1F8C}"/>
+                </a:ext>
+              </a:extLst>
+            </p:cNvPr>
+            <p:cNvPicPr/>
+            <p:nvPr/>
+          </p:nvPicPr>
+          <p:blipFill>
+            <a:blip r:embed="rId12"/>
+            <a:stretch/>
+          </p:blipFill>
+          <p:spPr>
+            <a:xfrm>
+              <a:off x="8424360" y="119520"/>
+              <a:ext cx="736200" cy="748800"/>
             </a:xfrm>
             <a:prstGeom prst="rect">
               <a:avLst/>
@@ -27241,6 +28337,351 @@
           </a:ln>
         </p:spPr>
       </p:pic>
+      <p:grpSp>
+        <p:nvGrpSpPr>
+          <p:cNvPr id="22" name="Group 21">
+            <a:extLst>
+              <a:ext uri="{FF2B5EF4-FFF2-40B4-BE49-F238E27FC236}">
+                <a16:creationId xmlns:a16="http://schemas.microsoft.com/office/drawing/2014/main" id="{1CD7492F-9B40-E866-A686-A320950DC54F}"/>
+              </a:ext>
+            </a:extLst>
+          </p:cNvPr>
+          <p:cNvGrpSpPr/>
+          <p:nvPr/>
+        </p:nvGrpSpPr>
+        <p:grpSpPr>
+          <a:xfrm>
+            <a:off x="8424360" y="119520"/>
+            <a:ext cx="1590840" cy="748800"/>
+            <a:chOff x="8424360" y="119520"/>
+            <a:chExt cx="1590840" cy="748800"/>
+          </a:xfrm>
+        </p:grpSpPr>
+        <p:grpSp>
+          <p:nvGrpSpPr>
+            <p:cNvPr id="16" name="Group 15">
+              <a:extLst>
+                <a:ext uri="{FF2B5EF4-FFF2-40B4-BE49-F238E27FC236}">
+                  <a16:creationId xmlns:a16="http://schemas.microsoft.com/office/drawing/2014/main" id="{2BB3E301-2C41-2604-9880-183FF169BD64}"/>
+                </a:ext>
+              </a:extLst>
+            </p:cNvPr>
+            <p:cNvGrpSpPr/>
+            <p:nvPr/>
+          </p:nvGrpSpPr>
+          <p:grpSpPr>
+            <a:xfrm>
+              <a:off x="9225000" y="124302"/>
+              <a:ext cx="790200" cy="708378"/>
+              <a:chOff x="9225000" y="124302"/>
+              <a:chExt cx="790200" cy="708378"/>
+            </a:xfrm>
+          </p:grpSpPr>
+          <p:pic>
+            <p:nvPicPr>
+              <p:cNvPr id="15" name="Picture 14">
+                <a:extLst>
+                  <a:ext uri="{FF2B5EF4-FFF2-40B4-BE49-F238E27FC236}">
+                    <a16:creationId xmlns:a16="http://schemas.microsoft.com/office/drawing/2014/main" id="{2F551320-79E9-3F0E-F819-AAEEFE09AFB9}"/>
+                  </a:ext>
+                </a:extLst>
+              </p:cNvPr>
+              <p:cNvPicPr>
+                <a:picLocks noChangeAspect="1"/>
+              </p:cNvPicPr>
+              <p:nvPr/>
+            </p:nvPicPr>
+            <p:blipFill>
+              <a:blip r:embed="rId5"/>
+              <a:stretch>
+                <a:fillRect/>
+              </a:stretch>
+            </p:blipFill>
+            <p:spPr>
+              <a:xfrm>
+                <a:off x="9262056" y="124302"/>
+                <a:ext cx="716666" cy="424533"/>
+              </a:xfrm>
+              <a:prstGeom prst="rect">
+                <a:avLst/>
+              </a:prstGeom>
+            </p:spPr>
+          </p:pic>
+          <p:grpSp>
+            <p:nvGrpSpPr>
+              <p:cNvPr id="3" name="Group 32">
+                <a:extLst>
+                  <a:ext uri="{FF2B5EF4-FFF2-40B4-BE49-F238E27FC236}">
+                    <a16:creationId xmlns:a16="http://schemas.microsoft.com/office/drawing/2014/main" id="{E66ADEC7-FFC8-DD88-113D-3B35DE76B76E}"/>
+                  </a:ext>
+                </a:extLst>
+              </p:cNvPr>
+              <p:cNvGrpSpPr/>
+              <p:nvPr/>
+            </p:nvGrpSpPr>
+            <p:grpSpPr>
+              <a:xfrm>
+                <a:off x="9225000" y="531360"/>
+                <a:ext cx="790200" cy="301320"/>
+                <a:chOff x="9225000" y="531360"/>
+                <a:chExt cx="790200" cy="301320"/>
+              </a:xfrm>
+            </p:grpSpPr>
+            <p:pic>
+              <p:nvPicPr>
+                <p:cNvPr id="6" name="Picture 29" descr="Synchrotron SOLEIL">
+                  <a:extLst>
+                    <a:ext uri="{FF2B5EF4-FFF2-40B4-BE49-F238E27FC236}">
+                      <a16:creationId xmlns:a16="http://schemas.microsoft.com/office/drawing/2014/main" id="{4DE64B31-FE11-6AD2-42E1-0540929F2375}"/>
+                    </a:ext>
+                  </a:extLst>
+                </p:cNvPr>
+                <p:cNvPicPr/>
+                <p:nvPr/>
+              </p:nvPicPr>
+              <p:blipFill>
+                <a:blip r:embed="rId6"/>
+                <a:stretch/>
+              </p:blipFill>
+              <p:spPr>
+                <a:xfrm>
+                  <a:off x="9225000" y="531360"/>
+                  <a:ext cx="547920" cy="264600"/>
+                </a:xfrm>
+                <a:prstGeom prst="rect">
+                  <a:avLst/>
+                </a:prstGeom>
+                <a:noFill/>
+                <a:ln w="0">
+                  <a:noFill/>
+                </a:ln>
+              </p:spPr>
+            </p:pic>
+            <p:pic>
+              <p:nvPicPr>
+                <p:cNvPr id="7" name="Picture 30" descr="DTU Physics">
+                  <a:extLst>
+                    <a:ext uri="{FF2B5EF4-FFF2-40B4-BE49-F238E27FC236}">
+                      <a16:creationId xmlns:a16="http://schemas.microsoft.com/office/drawing/2014/main" id="{AD9843F8-1D6E-6E50-B400-DEF6A4070400}"/>
+                    </a:ext>
+                  </a:extLst>
+                </p:cNvPr>
+                <p:cNvPicPr/>
+                <p:nvPr/>
+              </p:nvPicPr>
+              <p:blipFill>
+                <a:blip r:embed="rId7"/>
+                <a:stretch/>
+              </p:blipFill>
+              <p:spPr>
+                <a:xfrm>
+                  <a:off x="9814320" y="536400"/>
+                  <a:ext cx="200880" cy="296280"/>
+                </a:xfrm>
+                <a:prstGeom prst="rect">
+                  <a:avLst/>
+                </a:prstGeom>
+                <a:noFill/>
+                <a:ln w="0">
+                  <a:noFill/>
+                </a:ln>
+              </p:spPr>
+            </p:pic>
+          </p:grpSp>
+        </p:grpSp>
+        <p:pic>
+          <p:nvPicPr>
+            <p:cNvPr id="4" name="Picture 31">
+              <a:extLst>
+                <a:ext uri="{FF2B5EF4-FFF2-40B4-BE49-F238E27FC236}">
+                  <a16:creationId xmlns:a16="http://schemas.microsoft.com/office/drawing/2014/main" id="{6DDC59F5-58F2-8329-5474-1BB1AFEE1898}"/>
+                </a:ext>
+              </a:extLst>
+            </p:cNvPr>
+            <p:cNvPicPr/>
+            <p:nvPr/>
+          </p:nvPicPr>
+          <p:blipFill>
+            <a:blip r:embed="rId8"/>
+            <a:stretch/>
+          </p:blipFill>
+          <p:spPr>
+            <a:xfrm>
+              <a:off x="8424360" y="119520"/>
+              <a:ext cx="736200" cy="748800"/>
+            </a:xfrm>
+            <a:prstGeom prst="rect">
+              <a:avLst/>
+            </a:prstGeom>
+            <a:noFill/>
+            <a:ln w="0">
+              <a:noFill/>
+            </a:ln>
+          </p:spPr>
+        </p:pic>
+      </p:grpSp>
+      <p:pic>
+        <p:nvPicPr>
+          <p:cNvPr id="13" name="Picture 31">
+            <a:extLst>
+              <a:ext uri="{FF2B5EF4-FFF2-40B4-BE49-F238E27FC236}">
+                <a16:creationId xmlns:a16="http://schemas.microsoft.com/office/drawing/2014/main" id="{FB4355F7-61D1-7DFB-FF37-87C38EC9E50D}"/>
+              </a:ext>
+            </a:extLst>
+          </p:cNvPr>
+          <p:cNvPicPr/>
+          <p:nvPr/>
+        </p:nvPicPr>
+        <p:blipFill>
+          <a:blip r:embed="rId8"/>
+          <a:stretch/>
+        </p:blipFill>
+        <p:spPr>
+          <a:xfrm>
+            <a:off x="4855860" y="1774975"/>
+            <a:ext cx="736200" cy="748800"/>
+          </a:xfrm>
+          <a:prstGeom prst="rect">
+            <a:avLst/>
+          </a:prstGeom>
+          <a:noFill/>
+          <a:ln w="0">
+            <a:noFill/>
+          </a:ln>
+        </p:spPr>
+      </p:pic>
+      <p:grpSp>
+        <p:nvGrpSpPr>
+          <p:cNvPr id="17" name="Group 16">
+            <a:extLst>
+              <a:ext uri="{FF2B5EF4-FFF2-40B4-BE49-F238E27FC236}">
+                <a16:creationId xmlns:a16="http://schemas.microsoft.com/office/drawing/2014/main" id="{28359E41-62E9-328D-DA50-18B7D10213BA}"/>
+              </a:ext>
+            </a:extLst>
+          </p:cNvPr>
+          <p:cNvGrpSpPr/>
+          <p:nvPr/>
+        </p:nvGrpSpPr>
+        <p:grpSpPr>
+          <a:xfrm>
+            <a:off x="10404360" y="1709820"/>
+            <a:ext cx="790200" cy="708378"/>
+            <a:chOff x="9225000" y="124302"/>
+            <a:chExt cx="790200" cy="708378"/>
+          </a:xfrm>
+        </p:grpSpPr>
+        <p:pic>
+          <p:nvPicPr>
+            <p:cNvPr id="18" name="Picture 17">
+              <a:extLst>
+                <a:ext uri="{FF2B5EF4-FFF2-40B4-BE49-F238E27FC236}">
+                  <a16:creationId xmlns:a16="http://schemas.microsoft.com/office/drawing/2014/main" id="{C7A426AE-B45B-5837-BC6D-1D453A64CA1F}"/>
+                </a:ext>
+              </a:extLst>
+            </p:cNvPr>
+            <p:cNvPicPr>
+              <a:picLocks noChangeAspect="1"/>
+            </p:cNvPicPr>
+            <p:nvPr/>
+          </p:nvPicPr>
+          <p:blipFill>
+            <a:blip r:embed="rId5"/>
+            <a:stretch>
+              <a:fillRect/>
+            </a:stretch>
+          </p:blipFill>
+          <p:spPr>
+            <a:xfrm>
+              <a:off x="9262056" y="124302"/>
+              <a:ext cx="716666" cy="424533"/>
+            </a:xfrm>
+            <a:prstGeom prst="rect">
+              <a:avLst/>
+            </a:prstGeom>
+          </p:spPr>
+        </p:pic>
+        <p:grpSp>
+          <p:nvGrpSpPr>
+            <p:cNvPr id="19" name="Group 32">
+              <a:extLst>
+                <a:ext uri="{FF2B5EF4-FFF2-40B4-BE49-F238E27FC236}">
+                  <a16:creationId xmlns:a16="http://schemas.microsoft.com/office/drawing/2014/main" id="{7DBBBB81-4B2C-1E44-8FFB-7C8A1B72070F}"/>
+                </a:ext>
+              </a:extLst>
+            </p:cNvPr>
+            <p:cNvGrpSpPr/>
+            <p:nvPr/>
+          </p:nvGrpSpPr>
+          <p:grpSpPr>
+            <a:xfrm>
+              <a:off x="9225000" y="531360"/>
+              <a:ext cx="790200" cy="301320"/>
+              <a:chOff x="9225000" y="531360"/>
+              <a:chExt cx="790200" cy="301320"/>
+            </a:xfrm>
+          </p:grpSpPr>
+          <p:pic>
+            <p:nvPicPr>
+              <p:cNvPr id="20" name="Picture 29" descr="Synchrotron SOLEIL">
+                <a:extLst>
+                  <a:ext uri="{FF2B5EF4-FFF2-40B4-BE49-F238E27FC236}">
+                    <a16:creationId xmlns:a16="http://schemas.microsoft.com/office/drawing/2014/main" id="{94AA5246-7365-D56C-833F-1EB8C38DF9F5}"/>
+                  </a:ext>
+                </a:extLst>
+              </p:cNvPr>
+              <p:cNvPicPr/>
+              <p:nvPr/>
+            </p:nvPicPr>
+            <p:blipFill>
+              <a:blip r:embed="rId6"/>
+              <a:stretch/>
+            </p:blipFill>
+            <p:spPr>
+              <a:xfrm>
+                <a:off x="9225000" y="531360"/>
+                <a:ext cx="547920" cy="264600"/>
+              </a:xfrm>
+              <a:prstGeom prst="rect">
+                <a:avLst/>
+              </a:prstGeom>
+              <a:noFill/>
+              <a:ln w="0">
+                <a:noFill/>
+              </a:ln>
+            </p:spPr>
+          </p:pic>
+          <p:pic>
+            <p:nvPicPr>
+              <p:cNvPr id="21" name="Picture 30" descr="DTU Physics">
+                <a:extLst>
+                  <a:ext uri="{FF2B5EF4-FFF2-40B4-BE49-F238E27FC236}">
+                    <a16:creationId xmlns:a16="http://schemas.microsoft.com/office/drawing/2014/main" id="{30394D21-9E2B-73CF-55A2-65BDA5BA0CDD}"/>
+                  </a:ext>
+                </a:extLst>
+              </p:cNvPr>
+              <p:cNvPicPr/>
+              <p:nvPr/>
+            </p:nvPicPr>
+            <p:blipFill>
+              <a:blip r:embed="rId7"/>
+              <a:stretch/>
+            </p:blipFill>
+            <p:spPr>
+              <a:xfrm>
+                <a:off x="9814320" y="536400"/>
+                <a:ext cx="200880" cy="296280"/>
+              </a:xfrm>
+              <a:prstGeom prst="rect">
+                <a:avLst/>
+              </a:prstGeom>
+              <a:noFill/>
+              <a:ln w="0">
+                <a:noFill/>
+              </a:ln>
+            </p:spPr>
+          </p:pic>
+        </p:grpSp>
+      </p:grpSp>
     </p:spTree>
   </p:cSld>
   <p:clrMapOvr>
@@ -27486,7 +28927,7 @@
         </p:nvGraphicFramePr>
         <p:xfrm>
           <a:off x="548640" y="1920240"/>
-          <a:ext cx="11063880" cy="3291480"/>
+          <a:ext cx="11064240" cy="3290400"/>
         </p:xfrm>
         <a:graphic>
           <a:graphicData uri="http://schemas.openxmlformats.org/drawingml/2006/table">
@@ -28794,6 +30235,189 @@
           </a:ln>
         </p:spPr>
       </p:pic>
+      <p:grpSp>
+        <p:nvGrpSpPr>
+          <p:cNvPr id="2" name="Group 1">
+            <a:extLst>
+              <a:ext uri="{FF2B5EF4-FFF2-40B4-BE49-F238E27FC236}">
+                <a16:creationId xmlns:a16="http://schemas.microsoft.com/office/drawing/2014/main" id="{952A2BF9-F134-3902-D3DB-3901688850DE}"/>
+              </a:ext>
+            </a:extLst>
+          </p:cNvPr>
+          <p:cNvGrpSpPr/>
+          <p:nvPr/>
+        </p:nvGrpSpPr>
+        <p:grpSpPr>
+          <a:xfrm>
+            <a:off x="8424360" y="119520"/>
+            <a:ext cx="1590840" cy="748800"/>
+            <a:chOff x="8424360" y="119520"/>
+            <a:chExt cx="1590840" cy="748800"/>
+          </a:xfrm>
+        </p:grpSpPr>
+        <p:grpSp>
+          <p:nvGrpSpPr>
+            <p:cNvPr id="3" name="Group 2">
+              <a:extLst>
+                <a:ext uri="{FF2B5EF4-FFF2-40B4-BE49-F238E27FC236}">
+                  <a16:creationId xmlns:a16="http://schemas.microsoft.com/office/drawing/2014/main" id="{48F3A14A-5911-CBEB-572D-B5E682A9AE84}"/>
+                </a:ext>
+              </a:extLst>
+            </p:cNvPr>
+            <p:cNvGrpSpPr/>
+            <p:nvPr/>
+          </p:nvGrpSpPr>
+          <p:grpSpPr>
+            <a:xfrm>
+              <a:off x="9225000" y="124302"/>
+              <a:ext cx="790200" cy="708378"/>
+              <a:chOff x="9225000" y="124302"/>
+              <a:chExt cx="790200" cy="708378"/>
+            </a:xfrm>
+          </p:grpSpPr>
+          <p:pic>
+            <p:nvPicPr>
+              <p:cNvPr id="5" name="Picture 4">
+                <a:extLst>
+                  <a:ext uri="{FF2B5EF4-FFF2-40B4-BE49-F238E27FC236}">
+                    <a16:creationId xmlns:a16="http://schemas.microsoft.com/office/drawing/2014/main" id="{284EF612-795C-2887-FA9F-C1F1A583A83B}"/>
+                  </a:ext>
+                </a:extLst>
+              </p:cNvPr>
+              <p:cNvPicPr>
+                <a:picLocks noChangeAspect="1"/>
+              </p:cNvPicPr>
+              <p:nvPr/>
+            </p:nvPicPr>
+            <p:blipFill>
+              <a:blip r:embed="rId5"/>
+              <a:stretch>
+                <a:fillRect/>
+              </a:stretch>
+            </p:blipFill>
+            <p:spPr>
+              <a:xfrm>
+                <a:off x="9262056" y="124302"/>
+                <a:ext cx="716666" cy="424533"/>
+              </a:xfrm>
+              <a:prstGeom prst="rect">
+                <a:avLst/>
+              </a:prstGeom>
+            </p:spPr>
+          </p:pic>
+          <p:grpSp>
+            <p:nvGrpSpPr>
+              <p:cNvPr id="6" name="Group 32">
+                <a:extLst>
+                  <a:ext uri="{FF2B5EF4-FFF2-40B4-BE49-F238E27FC236}">
+                    <a16:creationId xmlns:a16="http://schemas.microsoft.com/office/drawing/2014/main" id="{19C9DAB2-BBFE-895F-049A-FDC2EB7E68DE}"/>
+                  </a:ext>
+                </a:extLst>
+              </p:cNvPr>
+              <p:cNvGrpSpPr/>
+              <p:nvPr/>
+            </p:nvGrpSpPr>
+            <p:grpSpPr>
+              <a:xfrm>
+                <a:off x="9225000" y="531360"/>
+                <a:ext cx="790200" cy="301320"/>
+                <a:chOff x="9225000" y="531360"/>
+                <a:chExt cx="790200" cy="301320"/>
+              </a:xfrm>
+            </p:grpSpPr>
+            <p:pic>
+              <p:nvPicPr>
+                <p:cNvPr id="7" name="Picture 29" descr="Synchrotron SOLEIL">
+                  <a:extLst>
+                    <a:ext uri="{FF2B5EF4-FFF2-40B4-BE49-F238E27FC236}">
+                      <a16:creationId xmlns:a16="http://schemas.microsoft.com/office/drawing/2014/main" id="{4CB42B84-622E-2DEE-BBCA-F74EA5282FA9}"/>
+                    </a:ext>
+                  </a:extLst>
+                </p:cNvPr>
+                <p:cNvPicPr/>
+                <p:nvPr/>
+              </p:nvPicPr>
+              <p:blipFill>
+                <a:blip r:embed="rId6"/>
+                <a:stretch/>
+              </p:blipFill>
+              <p:spPr>
+                <a:xfrm>
+                  <a:off x="9225000" y="531360"/>
+                  <a:ext cx="547920" cy="264600"/>
+                </a:xfrm>
+                <a:prstGeom prst="rect">
+                  <a:avLst/>
+                </a:prstGeom>
+                <a:noFill/>
+                <a:ln w="0">
+                  <a:noFill/>
+                </a:ln>
+              </p:spPr>
+            </p:pic>
+            <p:pic>
+              <p:nvPicPr>
+                <p:cNvPr id="8" name="Picture 30" descr="DTU Physics">
+                  <a:extLst>
+                    <a:ext uri="{FF2B5EF4-FFF2-40B4-BE49-F238E27FC236}">
+                      <a16:creationId xmlns:a16="http://schemas.microsoft.com/office/drawing/2014/main" id="{96A6E228-D4F1-4CDA-C285-752792FF8599}"/>
+                    </a:ext>
+                  </a:extLst>
+                </p:cNvPr>
+                <p:cNvPicPr/>
+                <p:nvPr/>
+              </p:nvPicPr>
+              <p:blipFill>
+                <a:blip r:embed="rId7"/>
+                <a:stretch/>
+              </p:blipFill>
+              <p:spPr>
+                <a:xfrm>
+                  <a:off x="9814320" y="536400"/>
+                  <a:ext cx="200880" cy="296280"/>
+                </a:xfrm>
+                <a:prstGeom prst="rect">
+                  <a:avLst/>
+                </a:prstGeom>
+                <a:noFill/>
+                <a:ln w="0">
+                  <a:noFill/>
+                </a:ln>
+              </p:spPr>
+            </p:pic>
+          </p:grpSp>
+        </p:grpSp>
+        <p:pic>
+          <p:nvPicPr>
+            <p:cNvPr id="4" name="Picture 31">
+              <a:extLst>
+                <a:ext uri="{FF2B5EF4-FFF2-40B4-BE49-F238E27FC236}">
+                  <a16:creationId xmlns:a16="http://schemas.microsoft.com/office/drawing/2014/main" id="{E517ECB5-4989-4291-C1A2-7DBF2DD38B37}"/>
+                </a:ext>
+              </a:extLst>
+            </p:cNvPr>
+            <p:cNvPicPr/>
+            <p:nvPr/>
+          </p:nvPicPr>
+          <p:blipFill>
+            <a:blip r:embed="rId8"/>
+            <a:stretch/>
+          </p:blipFill>
+          <p:spPr>
+            <a:xfrm>
+              <a:off x="8424360" y="119520"/>
+              <a:ext cx="736200" cy="748800"/>
+            </a:xfrm>
+            <a:prstGeom prst="rect">
+              <a:avLst/>
+            </a:prstGeom>
+            <a:noFill/>
+            <a:ln w="0">
+              <a:noFill/>
+            </a:ln>
+          </p:spPr>
+        </p:pic>
+      </p:grpSp>
     </p:spTree>
   </p:cSld>
   <p:clrMapOvr>

</xml_diff>